<commit_message>
deck: título "¿Sos humano?" en la portada
"Levantá la mano" pasa a kicker; el título grande queda "¿Sos humano?"
igual que la app. Regeneradas las salidas.

Co-Authored-By: Claude Sonnet 5 <noreply@anthropic.com>
Claude-Session: https://claude.ai/code/session_01MMPqo36BpSMUwH2Nf9NcSV
</commit_message>
<xml_diff>
--- a/deck/dist/humandetector-editable.pptx
+++ b/deck/dist/humandetector-editable.pptx
@@ -832,8 +832,8 @@
         </p:nvSpPr>
         <p:spPr>
           <a:xfrm>
-            <a:off x="762120" y="2251440"/>
-            <a:ext cx="8381880" cy="937800"/>
+            <a:off x="762120" y="2520720"/>
+            <a:ext cx="1536840" cy="226080"/>
           </a:xfrm>
           <a:prstGeom prst="rect">
             <a:avLst/>
@@ -850,6 +850,54 @@
           <a:p>
             <a:pPr/>
             <a:r>
+              <a:rPr lang="en-US" sz="1350" b="0" u="none" strike="noStrike">
+                <a:solidFill>
+                  <a:srgbClr val="3DDC84"/>
+                </a:solidFill>
+                <a:effectLst/>
+                <a:uFillTx/>
+                <a:latin typeface="JetBrainsMonoNF"/>
+                <a:ea typeface="JetBrainsMonoNF"/>
+              </a:rPr>
+              <a:t>LEVANTÁ LA MANO</a:t>
+            </a:r>
+            <a:endParaRPr lang="en-US" sz="1350" b="0" u="none" strike="noStrike">
+              <a:solidFill>
+                <a:srgbClr val="000000"/>
+              </a:solidFill>
+              <a:effectLst/>
+              <a:uFillTx/>
+              <a:latin typeface="Times New Roman"/>
+            </a:endParaRPr>
+          </a:p>
+        </p:txBody>
+      </p:sp>
+      <p:sp>
+        <p:nvSpPr>
+          <p:cNvPr id="10" name=""/>
+          <p:cNvSpPr txBox="1"/>
+          <p:nvPr/>
+        </p:nvSpPr>
+        <p:spPr>
+          <a:xfrm>
+            <a:off x="762120" y="2918160"/>
+            <a:ext cx="6798960" cy="937800"/>
+          </a:xfrm>
+          <a:prstGeom prst="rect">
+            <a:avLst/>
+          </a:prstGeom>
+          <a:noFill/>
+          <a:ln w="0">
+            <a:noFill/>
+          </a:ln>
+        </p:spPr>
+        <p:txBody>
+          <a:bodyPr wrap="none" lIns="0" tIns="0" rIns="0" bIns="0" anchor="t">
+            <a:spAutoFit/>
+          </a:bodyPr>
+          <a:p>
+            <a:pPr/>
+            <a:r>
               <a:rPr lang="en-US" sz="6600" b="1" u="none" strike="noStrike">
                 <a:solidFill>
                   <a:srgbClr val="EDEDED"/>
@@ -859,78 +907,30 @@
                 <a:latin typeface="Arial"/>
                 <a:ea typeface="Arial"/>
               </a:rPr>
-              <a:t>LEVANTÁ LA MANO:</a:t>
-            </a:r>
-            <a:endParaRPr lang="en-US" sz="6600" b="0" u="none" strike="noStrike">
-              <a:solidFill>
-                <a:srgbClr val="000000"/>
-              </a:solidFill>
-              <a:effectLst/>
-              <a:uFillTx/>
-              <a:latin typeface="Times New Roman"/>
-            </a:endParaRPr>
-          </a:p>
-        </p:txBody>
-      </p:sp>
-      <p:sp>
-        <p:nvSpPr>
-          <p:cNvPr id="10" name=""/>
-          <p:cNvSpPr txBox="1"/>
-          <p:nvPr/>
-        </p:nvSpPr>
-        <p:spPr>
-          <a:xfrm>
-            <a:off x="762120" y="3165840"/>
-            <a:ext cx="9034560" cy="937800"/>
-          </a:xfrm>
-          <a:prstGeom prst="rect">
-            <a:avLst/>
-          </a:prstGeom>
-          <a:noFill/>
-          <a:ln w="0">
-            <a:noFill/>
-          </a:ln>
-        </p:spPr>
-        <p:txBody>
-          <a:bodyPr wrap="none" lIns="0" tIns="0" rIns="0" bIns="0" anchor="t">
-            <a:spAutoFit/>
-          </a:bodyPr>
-          <a:p>
-            <a:pPr/>
+              <a:t>¿SOS </a:t>
+            </a:r>
             <a:r>
               <a:rPr lang="en-US" sz="6600" b="1" u="none" strike="noStrike">
                 <a:solidFill>
-                  <a:srgbClr val="EDEDED"/>
+                  <a:srgbClr val="3DDC84"/>
                 </a:solidFill>
                 <a:effectLst/>
                 <a:uFillTx/>
                 <a:latin typeface="Arial"/>
                 <a:ea typeface="Arial"/>
               </a:rPr>
-              <a:t>¿QUIÉN ES </a:t>
+              <a:t>HUMANO</a:t>
             </a:r>
             <a:r>
               <a:rPr lang="en-US" sz="6600" b="1" u="none" strike="noStrike">
                 <a:solidFill>
-                  <a:srgbClr val="3DDC84"/>
+                  <a:srgbClr val="EDEDED"/>
                 </a:solidFill>
                 <a:effectLst/>
                 <a:uFillTx/>
                 <a:latin typeface="Arial"/>
                 <a:ea typeface="Arial"/>
               </a:rPr>
-              <a:t>HUMANO</a:t>
-            </a:r>
-            <a:r>
-              <a:rPr lang="en-US" sz="6600" b="1" u="none" strike="noStrike">
-                <a:solidFill>
-                  <a:srgbClr val="EDEDED"/>
-                </a:solidFill>
-                <a:effectLst/>
-                <a:uFillTx/>
-                <a:latin typeface="Arial"/>
-                <a:ea typeface="Arial"/>
-              </a:rPr>
               <a:t>?</a:t>
             </a:r>
             <a:endParaRPr lang="en-US" sz="6600" b="0" u="none" strike="noStrike">
@@ -952,7 +952,7 @@
         </p:nvSpPr>
         <p:spPr>
           <a:xfrm>
-            <a:off x="762120" y="4315680"/>
+            <a:off x="762120" y="4077720"/>
             <a:ext cx="4584600" cy="233640"/>
           </a:xfrm>
           <a:prstGeom prst="rect">

</xml_diff>